<commit_message>
fix: webhook verification — parse raw QUERY_STRING to preserve dots in param names
PHP's  and parse_str() both convert dots to underscores in query
parameter names (hub.mode → hub_mode), breaking Meta's webhook
verification which uses hub.verify_token, hub.mode, and hub.challenge.

Manual parse of REQUEST_URI/QUERY_STRING preserves the exact keys.
</commit_message>
<xml_diff>
--- a/docs/KlassApp_Pitch_Deck.pptx
+++ b/docs/KlassApp_Pitch_Deck.pptx
@@ -2146,7 +2146,7 @@
                 <a:ea typeface="Arial" pitchFamily="34" charset="-122"/>
                 <a:cs typeface="Arial" pitchFamily="34" charset="-120"/>
               </a:rPr>
-              <a:t>Elijah (Rasta) — Founder &amp; CEO</a:t>
+              <a:t>Mucunguzi Moses — Founder</a:t>
             </a:r>
             <a:endParaRPr lang="en-US" sz="1300" dirty="0"/>
           </a:p>
@@ -2185,7 +2185,7 @@
                 <a:ea typeface="Arial" pitchFamily="34" charset="-122"/>
                 <a:cs typeface="Arial" pitchFamily="34" charset="-120"/>
               </a:rPr>
-              <a:t>Full-stack engineer. Built KlassApp from scratch. Deep understanding of Uganda's education ecosystem.</a:t>
+              <a:t>2x Founder. 5 years engineering experience. Deep understanding of Uganda's education and payments ecosystem.</a:t>
             </a:r>
             <a:endParaRPr lang="en-US" sz="1000" dirty="0"/>
           </a:p>
@@ -2246,7 +2246,7 @@
                 <a:ea typeface="Arial" pitchFamily="34" charset="-122"/>
                 <a:cs typeface="Arial" pitchFamily="34" charset="-120"/>
               </a:rPr>
-              <a:t>Co-founder — Technical &amp; Operations Lead</a:t>
+              <a:t>Mugisha Elijah — Co-founder &amp; CTO</a:t>
             </a:r>
             <a:endParaRPr lang="en-US" sz="1200" dirty="0"/>
           </a:p>
@@ -2285,7 +2285,7 @@
                 <a:ea typeface="Arial" pitchFamily="34" charset="-122"/>
                 <a:cs typeface="Arial" pitchFamily="34" charset="-120"/>
               </a:rPr>
-              <a:t>Technical architecture and operational leadership.</a:t>
+              <a:t>Fullstack engineer. Built the KlassApp platform from the ground up. Leads technical architecture and product.</a:t>
             </a:r>
             <a:endParaRPr lang="en-US" sz="1000" dirty="0"/>
           </a:p>
@@ -2385,7 +2385,7 @@
                 <a:ea typeface="Arial" pitchFamily="34" charset="-122"/>
                 <a:cs typeface="Arial" pitchFamily="34" charset="-120"/>
               </a:rPr>
-              <a:t>Raising a Pre-Seed Round</a:t>
+              <a:t>Raising $30K (UGX 100M) — Pre-Seed</a:t>
             </a:r>
             <a:endParaRPr lang="en-US" sz="1400" dirty="0"/>
           </a:p>
@@ -2485,7 +2485,7 @@
                 <a:ea typeface="Arial" pitchFamily="34" charset="-122"/>
                 <a:cs typeface="Arial" pitchFamily="34" charset="-120"/>
               </a:rPr>
-              <a:t>40%</a:t>
+              <a:t>50%</a:t>
             </a:r>
             <a:endParaRPr lang="en-US" sz="1000" dirty="0"/>
           </a:p>
@@ -2524,7 +2524,7 @@
                 <a:ea typeface="Arial" pitchFamily="34" charset="-122"/>
                 <a:cs typeface="Arial" pitchFamily="34" charset="-120"/>
               </a:rPr>
-              <a:t>Engineering &amp; AI — LIN integration, self-registration, analytics</a:t>
+              <a:t>Sales &amp; School Onboarding — dedicated onboarding team</a:t>
             </a:r>
             <a:endParaRPr lang="en-US" sz="950" dirty="0"/>
           </a:p>
@@ -2585,7 +2585,7 @@
                 <a:ea typeface="Arial" pitchFamily="34" charset="-122"/>
                 <a:cs typeface="Arial" pitchFamily="34" charset="-120"/>
               </a:rPr>
-              <a:t>30%</a:t>
+              <a:t>20%</a:t>
             </a:r>
             <a:endParaRPr lang="en-US" sz="1000" dirty="0"/>
           </a:p>
@@ -2624,7 +2624,7 @@
                 <a:ea typeface="Arial" pitchFamily="34" charset="-122"/>
                 <a:cs typeface="Arial" pitchFamily="34" charset="-120"/>
               </a:rPr>
-              <a:t>Sales &amp; School Onboarding — dedicated onboarding team</a:t>
+              <a:t>AI, Infra, Integrations &amp; Security</a:t>
             </a:r>
             <a:endParaRPr lang="en-US" sz="950" dirty="0"/>
           </a:p>
@@ -2724,7 +2724,7 @@
                 <a:ea typeface="Arial" pitchFamily="34" charset="-122"/>
                 <a:cs typeface="Arial" pitchFamily="34" charset="-120"/>
               </a:rPr>
-              <a:t>Infrastructure &amp; WhatsApp API — scale to 200+ schools</a:t>
+              <a:t>Legal, Compliance &amp; Operations</a:t>
             </a:r>
             <a:endParaRPr lang="en-US" sz="950" dirty="0"/>
           </a:p>
@@ -2824,7 +2824,7 @@
                 <a:ea typeface="Arial" pitchFamily="34" charset="-122"/>
                 <a:cs typeface="Arial" pitchFamily="34" charset="-120"/>
               </a:rPr>
-              <a:t>Legal, compliance, and operations</a:t>
+              <a:t>Operations &amp; Working Capital</a:t>
             </a:r>
             <a:endParaRPr lang="en-US" sz="950" dirty="0"/>
           </a:p>
@@ -2890,7 +2890,7 @@
                 <a:ea typeface="Arial" pitchFamily="34" charset="-122"/>
                 <a:cs typeface="Arial" pitchFamily="34" charset="-120"/>
               </a:rPr>
-              <a:t>Target: 200 schools in 18 months  →  $53K ARR  →  $47K net  →  Path to Series A</a:t>
+              <a:t>Target: 200 schools in 18 months  →  $53K ARR  →  $35K net  →  Path to Series A</a:t>
             </a:r>
             <a:endParaRPr lang="en-US" sz="1100" dirty="0"/>
           </a:p>
@@ -3180,7 +3180,7 @@
                 <a:ea typeface="Arial" pitchFamily="34" charset="-122"/>
                 <a:cs typeface="Arial" pitchFamily="34" charset="-120"/>
               </a:rPr>
-              <a:t>ugasch.com  ·  WhatsApp: +256 767 538805</a:t>
+              <a:t>klassapp.xyz  ·  hello@klassapp.xyz  ·  WhatsApp: +256 767 538805</a:t>
             </a:r>
             <a:endParaRPr lang="en-US" sz="1100" dirty="0"/>
           </a:p>
@@ -4102,7 +4102,7 @@
                 <a:ea typeface="Arial" pitchFamily="34" charset="-122"/>
                 <a:cs typeface="Arial" pitchFamily="34" charset="-120"/>
               </a:rPr>
-              <a:t>Parents get grades, fees, and attendance via WhatsApp. No app. No login. Just a message.</a:t>
+              <a:t>Parents get grades, fees, child's health updates, attendance, and more via WhatsApp. No app. No login. Just a message.</a:t>
             </a:r>
             <a:endParaRPr lang="en-US" sz="1300" dirty="0"/>
           </a:p>
@@ -4150,7 +4150,7 @@
                 <a:ea typeface="Arial" pitchFamily="34" charset="-122"/>
                 <a:cs typeface="Arial" pitchFamily="34" charset="-120"/>
               </a:rPr>
-              <a:t>Works on top of existing school systems — no rip-and-replace.</a:t>
+              <a:t>Works on top of existing school systems — no rip-and-replace. Just plug and connect.</a:t>
             </a:r>
             <a:endParaRPr lang="en-US" sz="1300" dirty="0"/>
           </a:p>
@@ -5369,6 +5369,30 @@
                 <a:cs typeface="Arial" pitchFamily="34" charset="-120"/>
               </a:rPr>
               <a:t>LIN integration: connects to Uganda's national Learner Identification Number system.</a:t>
+            </a:r>
+            <a:endParaRPr lang="en-US" sz="1150" dirty="0"/>
+          </a:p>
+          <a:p>
+            <a:pPr marL="342900" indent="-342900">
+              <a:lnSpc>
+                <a:spcPct val="125000"/>
+              </a:lnSpc>
+              <a:spcAft>
+                <a:spcPts val="400"/>
+              </a:spcAft>
+              <a:buSzPct val="100000"/>
+              <a:buChar char="•"/>
+            </a:pPr>
+            <a:r>
+              <a:rPr lang="en-US" sz="1150" dirty="0">
+                <a:solidFill>
+                  <a:srgbClr val="1E293B"/>
+                </a:solidFill>
+                <a:latin typeface="Arial" pitchFamily="34" charset="0"/>
+                <a:ea typeface="Arial" pitchFamily="34" charset="-122"/>
+                <a:cs typeface="Arial" pitchFamily="34" charset="-120"/>
+              </a:rPr>
+              <a:t>SchoolPay integration: automated fee status, payment confirmations, balance checks.</a:t>
             </a:r>
             <a:endParaRPr lang="en-US" sz="1150" dirty="0"/>
           </a:p>
@@ -9650,7 +9674,7 @@
                             <a:srgbClr val="1E293B"/>
                           </a:solidFill>
                         </a:rPr>
-                        <a:t>Infra &amp; AI Costs (~12%)</a:t>
+                        <a:t>Infra &amp; AI Costs (~17%)</a:t>
                       </a:r>
                       <a:endParaRPr lang="en-US" sz="1000" dirty="0"/>
                     </a:p>
@@ -9711,7 +9735,7 @@
                             <a:srgbClr val="1E293B"/>
                           </a:solidFill>
                         </a:rPr>
-                        <a:t>$803</a:t>
+                        <a:t>$1,137</a:t>
                       </a:r>
                       <a:endParaRPr lang="en-US" sz="1000" dirty="0"/>
                     </a:p>
@@ -9772,7 +9796,7 @@
                             <a:srgbClr val="1E293B"/>
                           </a:solidFill>
                         </a:rPr>
-                        <a:t>$1,605</a:t>
+                        <a:t>$2,274</a:t>
                       </a:r>
                       <a:endParaRPr lang="en-US" sz="1000" dirty="0"/>
                     </a:p>
@@ -9833,7 +9857,7 @@
                             <a:srgbClr val="1E293B"/>
                           </a:solidFill>
                         </a:rPr>
-                        <a:t>$3,211</a:t>
+                        <a:t>$4,549</a:t>
                       </a:r>
                       <a:endParaRPr lang="en-US" sz="1000" dirty="0"/>
                     </a:p>
@@ -9894,7 +9918,7 @@
                             <a:srgbClr val="1E293B"/>
                           </a:solidFill>
                         </a:rPr>
-                        <a:t>$6,422</a:t>
+                        <a:t>$9,097</a:t>
                       </a:r>
                       <a:endParaRPr lang="en-US" sz="1000" dirty="0"/>
                     </a:p>
@@ -9957,7 +9981,7 @@
                             <a:srgbClr val="1E6FD9"/>
                           </a:solidFill>
                         </a:rPr>
-                        <a:t>Net Revenue (USD/yr)</a:t>
+                        <a:t>VAT (18%)</a:t>
                       </a:r>
                       <a:endParaRPr lang="en-US" sz="1000" dirty="0"/>
                     </a:p>
@@ -10018,7 +10042,7 @@
                             <a:srgbClr val="1E293B"/>
                           </a:solidFill>
                         </a:rPr>
-                        <a:t>$5,886</a:t>
+                        <a:t>$1,204</a:t>
                       </a:r>
                       <a:endParaRPr lang="en-US" sz="1000" dirty="0"/>
                     </a:p>
@@ -10079,7 +10103,7 @@
                             <a:srgbClr val="1E293B"/>
                           </a:solidFill>
                         </a:rPr>
-                        <a:t>$11,773</a:t>
+                        <a:t>$2,408</a:t>
                       </a:r>
                       <a:endParaRPr lang="en-US" sz="1000" dirty="0"/>
                     </a:p>
@@ -10140,7 +10164,7 @@
                             <a:srgbClr val="1E293B"/>
                           </a:solidFill>
                         </a:rPr>
-                        <a:t>$23,546</a:t>
+                        <a:t>$4,816</a:t>
                       </a:r>
                       <a:endParaRPr lang="en-US" sz="1000" dirty="0"/>
                     </a:p>
@@ -10201,7 +10225,7 @@
                             <a:srgbClr val="1E293B"/>
                           </a:solidFill>
                         </a:rPr>
-                        <a:t>$47,092</a:t>
+                        <a:t>$9,632</a:t>
                       </a:r>
                       <a:endParaRPr lang="en-US" sz="1000" dirty="0"/>
                     </a:p>
@@ -10264,7 +10288,7 @@
                             <a:srgbClr val="1E293B"/>
                           </a:solidFill>
                         </a:rPr>
-                        <a:t>Gross Margin</a:t>
+                        <a:t>Net Revenue (USD/yr)</a:t>
                       </a:r>
                       <a:endParaRPr lang="en-US" sz="1000" dirty="0"/>
                     </a:p>
@@ -10325,7 +10349,7 @@
                             <a:srgbClr val="1E293B"/>
                           </a:solidFill>
                         </a:rPr>
-                        <a:t>88%</a:t>
+                        <a:t>$4,348</a:t>
                       </a:r>
                       <a:endParaRPr lang="en-US" sz="1000" dirty="0"/>
                     </a:p>
@@ -10386,7 +10410,7 @@
                             <a:srgbClr val="1E293B"/>
                           </a:solidFill>
                         </a:rPr>
-                        <a:t>88%</a:t>
+                        <a:t>$8,696</a:t>
                       </a:r>
                       <a:endParaRPr lang="en-US" sz="1000" dirty="0"/>
                     </a:p>
@@ -10447,7 +10471,7 @@
                             <a:srgbClr val="1E293B"/>
                           </a:solidFill>
                         </a:rPr>
-                        <a:t>88%</a:t>
+                        <a:t>$17,392</a:t>
                       </a:r>
                       <a:endParaRPr lang="en-US" sz="1000" dirty="0"/>
                     </a:p>
@@ -10508,7 +10532,314 @@
                             <a:srgbClr val="1E293B"/>
                           </a:solidFill>
                         </a:rPr>
-                        <a:t>88%</a:t>
+                        <a:t>$34,785</a:t>
+                      </a:r>
+                      <a:endParaRPr lang="en-US" sz="1000" dirty="0"/>
+                    </a:p>
+                  </a:txBody>
+                  <a:tcPr marL="91440" marR="91440" marT="45720" marB="45720">
+                    <a:lnL w="6350" cap="flat" cmpd="sng" algn="ctr">
+                      <a:solidFill>
+                        <a:srgbClr val="E2E8F0"/>
+                      </a:solidFill>
+                      <a:prstDash val="solid"/>
+                      <a:round/>
+                      <a:headEnd type="none" w="med" len="med"/>
+                      <a:tailEnd type="none" w="med" len="med"/>
+                    </a:lnL>
+                    <a:lnR w="6350" cap="flat" cmpd="sng" algn="ctr">
+                      <a:solidFill>
+                        <a:srgbClr val="E2E8F0"/>
+                      </a:solidFill>
+                      <a:prstDash val="solid"/>
+                      <a:round/>
+                      <a:headEnd type="none" w="med" len="med"/>
+                      <a:tailEnd type="none" w="med" len="med"/>
+                    </a:lnR>
+                    <a:lnT w="6350" cap="flat" cmpd="sng" algn="ctr">
+                      <a:solidFill>
+                        <a:srgbClr val="E2E8F0"/>
+                      </a:solidFill>
+                      <a:prstDash val="solid"/>
+                      <a:round/>
+                      <a:headEnd type="none" w="med" len="med"/>
+                      <a:tailEnd type="none" w="med" len="med"/>
+                    </a:lnT>
+                    <a:lnB w="6350" cap="flat" cmpd="sng" algn="ctr">
+                      <a:solidFill>
+                        <a:srgbClr val="E2E8F0"/>
+                      </a:solidFill>
+                      <a:prstDash val="solid"/>
+                      <a:round/>
+                      <a:headEnd type="none" w="med" len="med"/>
+                      <a:tailEnd type="none" w="med" len="med"/>
+                    </a:lnB>
+                    <a:solidFill>
+                      <a:srgbClr val="FFFFFF"/>
+                    </a:solidFill>
+                  </a:tcPr>
+                </a:tc>
+              </a:tr>
+              <a:tr h="274320">
+                <a:tc>
+                  <a:txBody>
+                    <a:bodyPr/>
+                    <a:lstStyle/>
+                    <a:p>
+                      <a:pPr indent="0" marL="0">
+                        <a:buNone/>
+                      </a:pPr>
+                      <a:r>
+                        <a:rPr lang="en-US" sz="1000" dirty="0">
+                          <a:solidFill>
+                            <a:srgbClr val="1E293B"/>
+                          </a:solidFill>
+                        </a:rPr>
+                        <a:t>Gross Margin</a:t>
+                      </a:r>
+                      <a:endParaRPr lang="en-US" sz="1000" dirty="0"/>
+                    </a:p>
+                  </a:txBody>
+                  <a:tcPr marL="91440" marR="91440" marT="45720" marB="45720">
+                    <a:lnL w="6350" cap="flat" cmpd="sng" algn="ctr">
+                      <a:solidFill>
+                        <a:srgbClr val="E2E8F0"/>
+                      </a:solidFill>
+                      <a:prstDash val="solid"/>
+                      <a:round/>
+                      <a:headEnd type="none" w="med" len="med"/>
+                      <a:tailEnd type="none" w="med" len="med"/>
+                    </a:lnL>
+                    <a:lnR w="6350" cap="flat" cmpd="sng" algn="ctr">
+                      <a:solidFill>
+                        <a:srgbClr val="E2E8F0"/>
+                      </a:solidFill>
+                      <a:prstDash val="solid"/>
+                      <a:round/>
+                      <a:headEnd type="none" w="med" len="med"/>
+                      <a:tailEnd type="none" w="med" len="med"/>
+                    </a:lnR>
+                    <a:lnT w="6350" cap="flat" cmpd="sng" algn="ctr">
+                      <a:solidFill>
+                        <a:srgbClr val="E2E8F0"/>
+                      </a:solidFill>
+                      <a:prstDash val="solid"/>
+                      <a:round/>
+                      <a:headEnd type="none" w="med" len="med"/>
+                      <a:tailEnd type="none" w="med" len="med"/>
+                    </a:lnT>
+                    <a:lnB w="6350" cap="flat" cmpd="sng" algn="ctr">
+                      <a:solidFill>
+                        <a:srgbClr val="E2E8F0"/>
+                      </a:solidFill>
+                      <a:prstDash val="solid"/>
+                      <a:round/>
+                      <a:headEnd type="none" w="med" len="med"/>
+                      <a:tailEnd type="none" w="med" len="med"/>
+                    </a:lnB>
+                    <a:solidFill>
+                      <a:srgbClr val="FFFFFF"/>
+                    </a:solidFill>
+                  </a:tcPr>
+                </a:tc>
+                <a:tc>
+                  <a:txBody>
+                    <a:bodyPr/>
+                    <a:lstStyle/>
+                    <a:p>
+                      <a:pPr algn="r" indent="0" marL="0">
+                        <a:buNone/>
+                      </a:pPr>
+                      <a:r>
+                        <a:rPr lang="en-US" sz="1000" dirty="0">
+                          <a:solidFill>
+                            <a:srgbClr val="1E293B"/>
+                          </a:solidFill>
+                        </a:rPr>
+                        <a:t>65%</a:t>
+                      </a:r>
+                      <a:endParaRPr lang="en-US" sz="1000" dirty="0"/>
+                    </a:p>
+                  </a:txBody>
+                  <a:tcPr marL="91440" marR="91440" marT="45720" marB="45720">
+                    <a:lnL w="6350" cap="flat" cmpd="sng" algn="ctr">
+                      <a:solidFill>
+                        <a:srgbClr val="E2E8F0"/>
+                      </a:solidFill>
+                      <a:prstDash val="solid"/>
+                      <a:round/>
+                      <a:headEnd type="none" w="med" len="med"/>
+                      <a:tailEnd type="none" w="med" len="med"/>
+                    </a:lnL>
+                    <a:lnR w="6350" cap="flat" cmpd="sng" algn="ctr">
+                      <a:solidFill>
+                        <a:srgbClr val="E2E8F0"/>
+                      </a:solidFill>
+                      <a:prstDash val="solid"/>
+                      <a:round/>
+                      <a:headEnd type="none" w="med" len="med"/>
+                      <a:tailEnd type="none" w="med" len="med"/>
+                    </a:lnR>
+                    <a:lnT w="6350" cap="flat" cmpd="sng" algn="ctr">
+                      <a:solidFill>
+                        <a:srgbClr val="E2E8F0"/>
+                      </a:solidFill>
+                      <a:prstDash val="solid"/>
+                      <a:round/>
+                      <a:headEnd type="none" w="med" len="med"/>
+                      <a:tailEnd type="none" w="med" len="med"/>
+                    </a:lnT>
+                    <a:lnB w="6350" cap="flat" cmpd="sng" algn="ctr">
+                      <a:solidFill>
+                        <a:srgbClr val="E2E8F0"/>
+                      </a:solidFill>
+                      <a:prstDash val="solid"/>
+                      <a:round/>
+                      <a:headEnd type="none" w="med" len="med"/>
+                      <a:tailEnd type="none" w="med" len="med"/>
+                    </a:lnB>
+                    <a:solidFill>
+                      <a:srgbClr val="FFFFFF"/>
+                    </a:solidFill>
+                  </a:tcPr>
+                </a:tc>
+                <a:tc>
+                  <a:txBody>
+                    <a:bodyPr/>
+                    <a:lstStyle/>
+                    <a:p>
+                      <a:pPr algn="r" indent="0" marL="0">
+                        <a:buNone/>
+                      </a:pPr>
+                      <a:r>
+                        <a:rPr lang="en-US" sz="1000" dirty="0">
+                          <a:solidFill>
+                            <a:srgbClr val="1E293B"/>
+                          </a:solidFill>
+                        </a:rPr>
+                        <a:t>65%</a:t>
+                      </a:r>
+                      <a:endParaRPr lang="en-US" sz="1000" dirty="0"/>
+                    </a:p>
+                  </a:txBody>
+                  <a:tcPr marL="91440" marR="91440" marT="45720" marB="45720">
+                    <a:lnL w="6350" cap="flat" cmpd="sng" algn="ctr">
+                      <a:solidFill>
+                        <a:srgbClr val="E2E8F0"/>
+                      </a:solidFill>
+                      <a:prstDash val="solid"/>
+                      <a:round/>
+                      <a:headEnd type="none" w="med" len="med"/>
+                      <a:tailEnd type="none" w="med" len="med"/>
+                    </a:lnL>
+                    <a:lnR w="6350" cap="flat" cmpd="sng" algn="ctr">
+                      <a:solidFill>
+                        <a:srgbClr val="E2E8F0"/>
+                      </a:solidFill>
+                      <a:prstDash val="solid"/>
+                      <a:round/>
+                      <a:headEnd type="none" w="med" len="med"/>
+                      <a:tailEnd type="none" w="med" len="med"/>
+                    </a:lnR>
+                    <a:lnT w="6350" cap="flat" cmpd="sng" algn="ctr">
+                      <a:solidFill>
+                        <a:srgbClr val="E2E8F0"/>
+                      </a:solidFill>
+                      <a:prstDash val="solid"/>
+                      <a:round/>
+                      <a:headEnd type="none" w="med" len="med"/>
+                      <a:tailEnd type="none" w="med" len="med"/>
+                    </a:lnT>
+                    <a:lnB w="6350" cap="flat" cmpd="sng" algn="ctr">
+                      <a:solidFill>
+                        <a:srgbClr val="E2E8F0"/>
+                      </a:solidFill>
+                      <a:prstDash val="solid"/>
+                      <a:round/>
+                      <a:headEnd type="none" w="med" len="med"/>
+                      <a:tailEnd type="none" w="med" len="med"/>
+                    </a:lnB>
+                    <a:solidFill>
+                      <a:srgbClr val="FFFFFF"/>
+                    </a:solidFill>
+                  </a:tcPr>
+                </a:tc>
+                <a:tc>
+                  <a:txBody>
+                    <a:bodyPr/>
+                    <a:lstStyle/>
+                    <a:p>
+                      <a:pPr algn="r" indent="0" marL="0">
+                        <a:buNone/>
+                      </a:pPr>
+                      <a:r>
+                        <a:rPr lang="en-US" sz="1000" dirty="0">
+                          <a:solidFill>
+                            <a:srgbClr val="1E293B"/>
+                          </a:solidFill>
+                        </a:rPr>
+                        <a:t>65%</a:t>
+                      </a:r>
+                      <a:endParaRPr lang="en-US" sz="1000" dirty="0"/>
+                    </a:p>
+                  </a:txBody>
+                  <a:tcPr marL="91440" marR="91440" marT="45720" marB="45720">
+                    <a:lnL w="6350" cap="flat" cmpd="sng" algn="ctr">
+                      <a:solidFill>
+                        <a:srgbClr val="E2E8F0"/>
+                      </a:solidFill>
+                      <a:prstDash val="solid"/>
+                      <a:round/>
+                      <a:headEnd type="none" w="med" len="med"/>
+                      <a:tailEnd type="none" w="med" len="med"/>
+                    </a:lnL>
+                    <a:lnR w="6350" cap="flat" cmpd="sng" algn="ctr">
+                      <a:solidFill>
+                        <a:srgbClr val="E2E8F0"/>
+                      </a:solidFill>
+                      <a:prstDash val="solid"/>
+                      <a:round/>
+                      <a:headEnd type="none" w="med" len="med"/>
+                      <a:tailEnd type="none" w="med" len="med"/>
+                    </a:lnR>
+                    <a:lnT w="6350" cap="flat" cmpd="sng" algn="ctr">
+                      <a:solidFill>
+                        <a:srgbClr val="E2E8F0"/>
+                      </a:solidFill>
+                      <a:prstDash val="solid"/>
+                      <a:round/>
+                      <a:headEnd type="none" w="med" len="med"/>
+                      <a:tailEnd type="none" w="med" len="med"/>
+                    </a:lnT>
+                    <a:lnB w="6350" cap="flat" cmpd="sng" algn="ctr">
+                      <a:solidFill>
+                        <a:srgbClr val="E2E8F0"/>
+                      </a:solidFill>
+                      <a:prstDash val="solid"/>
+                      <a:round/>
+                      <a:headEnd type="none" w="med" len="med"/>
+                      <a:tailEnd type="none" w="med" len="med"/>
+                    </a:lnB>
+                    <a:solidFill>
+                      <a:srgbClr val="FFFFFF"/>
+                    </a:solidFill>
+                  </a:tcPr>
+                </a:tc>
+                <a:tc>
+                  <a:txBody>
+                    <a:bodyPr/>
+                    <a:lstStyle/>
+                    <a:p>
+                      <a:pPr algn="r" indent="0" marL="0">
+                        <a:buNone/>
+                      </a:pPr>
+                      <a:r>
+                        <a:rPr lang="en-US" sz="1000" dirty="0">
+                          <a:solidFill>
+                            <a:srgbClr val="1E293B"/>
+                          </a:solidFill>
+                        </a:rPr>
+                        <a:t>65%</a:t>
                       </a:r>
                       <a:endParaRPr lang="en-US" sz="1000" dirty="0"/>
                     </a:p>
@@ -11453,7 +11784,7 @@
                 <a:ea typeface="Arial" pitchFamily="34" charset="-122"/>
                 <a:cs typeface="Arial" pitchFamily="34" charset="-120"/>
               </a:rPr>
-              <a:t>Partnerships: Ministry of Education, school associations, education NGOs, mobile money providers.</a:t>
+              <a:t>Partnerships: Ministry of Education, school associations, education NGOs, mobile money providers, School ERPs, and SchoolPay.</a:t>
             </a:r>
             <a:endParaRPr lang="en-US" sz="1250" dirty="0"/>
           </a:p>
@@ -12153,7 +12484,7 @@
                 <a:ea typeface="Arial" pitchFamily="34" charset="-122"/>
                 <a:cs typeface="Arial" pitchFamily="34" charset="-120"/>
               </a:rPr>
-              <a:t>$53K ARR  ·  $47K net</a:t>
+              <a:t>$53K ARR  ·  $35K net</a:t>
             </a:r>
             <a:endParaRPr lang="en-US" sz="1000" dirty="0"/>
           </a:p>

</xml_diff>